<commit_message>
docs(feat-02): presentaciones y bitácora con el estado del despliegue DEV en Swarm
Co-Authored-By: Claude Opus 5.5 <noreply@anthropic.com>
</commit_message>
<xml_diff>
--- a/entregables-feat-02/04_presentaciones/FEAT-02_avance_PMV_ruta_DEV.pptx
+++ b/entregables-feat-02/04_presentaciones/FEAT-02_avance_PMV_ruta_DEV.pptx
@@ -118,13 +118,13 @@
   <p:extLst>
     <p:ext uri="{521415D9-36F7-43E2-AB2F-B90AF26B5E84}">
       <p14:sectionLst xmlns:p14="http://schemas.microsoft.com/office/powerpoint/2010/main">
-        <p14:section name="Resumen" id="{83a8ef09-f15d-a8de-286a-c0b1ec6dac34}">
+        <p14:section name="Resumen" id="{896a9e97-ad1d-d18d-7998-277d0469ea13}">
           <p14:sldIdLst>
             <p14:sldId id="256"/>
             <p14:sldId id="257"/>
           </p14:sldIdLst>
         </p14:section>
-        <p14:section name="Lo construido" id="{61e4bddb-35ff-8c61-d6a2-9a32b676dce4}">
+        <p14:section name="Lo construido" id="{35e41d7c-0102-689b-eb6d-3972be922d3e}">
           <p14:sldIdLst>
             <p14:sldId id="258"/>
             <p14:sldId id="259"/>
@@ -132,19 +132,19 @@
             <p14:sldId id="261"/>
           </p14:sldIdLst>
         </p14:section>
-        <p14:section name="PMV y cronograma" id="{ae751e2c-1477-3163-97b3-23dafddb7f6f}">
+        <p14:section name="PMV y cronograma" id="{e38d176a-e39c-0203-1082-047d5812ffec}">
           <p14:sldIdLst>
             <p14:sldId id="262"/>
             <p14:sldId id="263"/>
           </p14:sldIdLst>
         </p14:section>
-        <p14:section name="Paso a paso DEV" id="{a8f3c255-6484-feb4-543f-40c6cb618c9c}">
+        <p14:section name="Paso a paso DEV" id="{af7fe1f8-6b4d-fb33-b349-9bd82334c408}">
           <p14:sldIdLst>
             <p14:sldId id="264"/>
             <p14:sldId id="265"/>
           </p14:sldIdLst>
         </p14:section>
-        <p14:section name="Cierre" id="{c2d221b0-9794-73c4-707b-cd1710440090}">
+        <p14:section name="Cierre" id="{646771f9-bb72-7845-6fe7-2aff209d0be0}">
           <p14:sldIdLst>
             <p14:sldId id="266"/>
             <p14:sldId id="267"/>
@@ -3009,7 +3009,7 @@
                   <a:schemeClr val="accent6"/>
                 </a:solidFill>
               </a:rPr>
-              <a:t>Avance FEAT-02, PMV de voz y paso a paso para llevar la maqueta a un ambiente DEV · octubre 2026</a:t>
+              <a:t>Avance FEAT-02, PMV de voz y despliegue en el ambiente DEV de tres servidores · actualizado 14-oct-2026</a:t>
             </a:r>
             <a:endParaRPr lang="en-US" sz="2000" dirty="0"/>
           </a:p>
@@ -3072,7 +3072,7 @@
                   <a:schemeClr val="tx2"/>
                 </a:solidFill>
               </a:rPr>
-              <a:t>Ocho pasos de la VM vacía a la maqueta verificada</a:t>
+              <a:t>Ocho pasos para reproducir el DEV de tres nodos</a:t>
             </a:r>
             <a:endParaRPr lang="en-US" sz="3000" dirty="0"/>
           </a:p>
@@ -3169,7 +3169,7 @@
                   <a:schemeClr val="tx2"/>
                 </a:solidFill>
               </a:rPr>
-              <a:t>Preparar la VM</a:t>
+              <a:t>Preparar los nodos</a:t>
             </a:r>
             <a:endParaRPr lang="en-US" sz="1700" dirty="0"/>
           </a:p>
@@ -3205,7 +3205,7 @@
                   <a:schemeClr val="tx1"/>
                 </a:solidFill>
               </a:rPr>
-              <a:t>Docker + Compose, módulos esp4/xfrm_user y nf_tables.</a:t>
+              <a:t>Docker en las 3 VM, módulos esp4/xfrm_user y nf_tables.</a:t>
             </a:r>
             <a:endParaRPr lang="en-US" sz="1400" dirty="0"/>
           </a:p>
@@ -3302,7 +3302,7 @@
                   <a:schemeClr val="tx2"/>
                 </a:solidFill>
               </a:rPr>
-              <a:t>Clonar la rama</a:t>
+              <a:t>Formar el Swarm</a:t>
             </a:r>
             <a:endParaRPr lang="en-US" sz="1700" dirty="0"/>
           </a:p>
@@ -3338,7 +3338,7 @@
                   <a:schemeClr val="tx1"/>
                 </a:solidFill>
               </a:rPr>
-              <a:t>git clone … &amp;&amp; git checkout feature/feat-02</a:t>
+              <a:t>docker swarm init/join; etiquetas role=core-ims, database, ivr.</a:t>
             </a:r>
             <a:endParaRPr lang="en-US" sz="1400" dirty="0"/>
           </a:p>
@@ -3435,7 +3435,7 @@
                   <a:schemeClr val="tx2"/>
                 </a:solidFill>
               </a:rPr>
-              <a:t>Ajustar .env</a:t>
+              <a:t>Crear redes overlay</a:t>
             </a:r>
             <a:endParaRPr lang="en-US" sz="1700" dirty="0"/>
           </a:p>
@@ -3471,7 +3471,7 @@
                   <a:schemeClr val="tx1"/>
                 </a:solidFill>
               </a:rPr>
-              <a:t>IPs de la red y dominio (MCC/MNC) si cambian.</a:t>
+              <a:t>mims3_network, mims3_isc y mims3_management (external).</a:t>
             </a:r>
             <a:endParaRPr lang="en-US" sz="1400" dirty="0"/>
           </a:p>
@@ -3568,7 +3568,7 @@
                   <a:schemeClr val="tx2"/>
                 </a:solidFill>
               </a:rPr>
-              <a:t>Construir y levantar</a:t>
+              <a:t>Construir imágenes</a:t>
             </a:r>
             <a:endParaRPr lang="en-US" sz="1700" dirty="0"/>
           </a:p>
@@ -3604,7 +3604,7 @@
                   <a:schemeClr val="tx1"/>
                 </a:solidFill>
               </a:rPr>
-              <a:t>docker compose up -d --build (14 contenedores).</a:t>
+              <a:t>En cada nodo, las de los servicios que aloja.</a:t>
             </a:r>
             <a:endParaRPr lang="en-US" sz="1400" dirty="0"/>
           </a:p>
@@ -3701,7 +3701,7 @@
                   <a:schemeClr val="tx2"/>
                 </a:solidFill>
               </a:rPr>
-              <a:t>Provisionar HSS</a:t>
+              <a:t>Desplegar el stack</a:t>
             </a:r>
             <a:endParaRPr lang="en-US" sz="1700" dirty="0"/>
           </a:p>
@@ -3737,7 +3737,7 @@
                   <a:schemeClr val="tx1"/>
                 </a:solidFill>
               </a:rPr>
-              <a:t>scripts/provision_hss.sh (suscriptores e iFC).</a:t>
+              <a:t>compose + docker-compose.swarm.yml (.env + .env.swarm) → stack mims3.</a:t>
             </a:r>
             <a:endParaRPr lang="en-US" sz="1400" dirty="0"/>
           </a:p>
@@ -3834,7 +3834,7 @@
                   <a:schemeClr val="tx2"/>
                 </a:solidFill>
               </a:rPr>
-              <a:t>Probar E2E</a:t>
+              <a:t>Provisionar HSS</a:t>
             </a:r>
             <a:endParaRPr lang="en-US" sz="1700" dirty="0"/>
           </a:p>
@@ -3870,7 +3870,7 @@
                   <a:schemeClr val="tx1"/>
                 </a:solidFill>
               </a:rPr>
-              <a:t>bash scripts/test_maqueta.sh → 22/22</a:t>
+              <a:t>Desde la UI (Configuración) o scripts/provision_hss.sh.</a:t>
             </a:r>
             <a:endParaRPr lang="en-US" sz="1400" dirty="0"/>
           </a:p>
@@ -3967,7 +3967,7 @@
                   <a:schemeClr val="tx2"/>
                 </a:solidFill>
               </a:rPr>
-              <a:t>Verificar 3GPP</a:t>
+              <a:t>Probar E2E</a:t>
             </a:r>
             <a:endParaRPr lang="en-US" sz="1700" dirty="0"/>
           </a:p>
@@ -4003,7 +4003,7 @@
                   <a:schemeClr val="tx1"/>
                 </a:solidFill>
               </a:rPr>
-              <a:t>bash scripts/capture_iteration.sh &lt;dir&gt; → 27/27</a:t>
+              <a:t>SWARM_MODE=1 bash scripts/test_maqueta.sh → 22/22</a:t>
             </a:r>
             <a:endParaRPr lang="en-US" sz="1400" dirty="0"/>
           </a:p>
@@ -4100,7 +4100,7 @@
                   <a:schemeClr val="tx2"/>
                 </a:solidFill>
               </a:rPr>
-              <a:t>Abrir acceso</a:t>
+              <a:t>Verificar 3GPP</a:t>
             </a:r>
             <a:endParaRPr lang="en-US" sz="1700" dirty="0"/>
           </a:p>
@@ -4136,7 +4136,7 @@
                   <a:schemeClr val="tx1"/>
                 </a:solidFill>
               </a:rPr>
-              <a:t>Ruta LAN→172.32.0.0/24 y softphones (tutorial).</a:t>
+              <a:t>bash scripts/capture_iteration_swarm.sh &lt;dir&gt; → 27/28</a:t>
             </a:r>
             <a:endParaRPr lang="en-US" sz="1400" dirty="0"/>
           </a:p>
@@ -4351,7 +4351,7 @@
       </p:sp>
       <p:sp>
         <p:nvSpPr>
-          <p:cNvPr id="6" name="card-Softphones comerciales"/>
+          <p:cNvPr id="6" name="card-Softphones externos en DEV"/>
           <p:cNvSpPr/>
           <p:nvPr/>
         </p:nvSpPr>
@@ -4406,7 +4406,7 @@
                   <a:schemeClr val="tx2"/>
                 </a:solidFill>
               </a:rPr>
-              <a:t>Softphones comerciales</a:t>
+              <a:t>Softphones externos en DEV</a:t>
             </a:r>
             <a:endParaRPr lang="en-US" sz="1800" dirty="0"/>
           </a:p>
@@ -4442,7 +4442,7 @@
                   <a:schemeClr val="tx1"/>
                 </a:solidFill>
               </a:rPr>
-              <a:t>No hacen IMS-AKA ni IPsec. En DEV se habilita un perfil SIP Digest (TS 33.203 Anexo N) aislado; producción solo AKA.</a:t>
+              <a:t>No hacen IMS-AKA ni IPsec, y el P-CSCF solo es alcanzable dentro de la overlay: hace falta publicar el P-CSCF y un perfil Digest aislado (TS 33.203 Anexo N).</a:t>
             </a:r>
             <a:endParaRPr lang="en-US" sz="1400" dirty="0"/>
           </a:p>
@@ -4549,7 +4549,7 @@
       </p:sp>
       <p:sp>
         <p:nvSpPr>
-          <p:cNvPr id="12" name="card-Dependencia de infraestructura"/>
+          <p:cNvPr id="12" name="card-MTU de la red DEV"/>
           <p:cNvSpPr/>
           <p:nvPr/>
         </p:nvSpPr>
@@ -4604,7 +4604,7 @@
                   <a:schemeClr val="tx2"/>
                 </a:solidFill>
               </a:rPr>
-              <a:t>Dependencia de infraestructura</a:t>
+              <a:t>MTU de la red DEV</a:t>
             </a:r>
             <a:endParaRPr lang="en-US" sz="1800" dirty="0"/>
           </a:p>
@@ -4640,7 +4640,7 @@
                   <a:schemeClr val="tx1"/>
                 </a:solidFill>
               </a:rPr>
-              <a:t>Sin VM DEV no avanza la validación compartida: es la primera tarea de la ruta crítica.</a:t>
+              <a:t>La overlay de Swarm queda en 1450 B: REGISTER e INVITE por UDP se fragmentan (G3, RFC 3261 §18.1.1). Pedir jumbo frames o pasar Gm a SIP sobre TCP.</a:t>
             </a:r>
             <a:endParaRPr lang="en-US" sz="1400" dirty="0"/>
           </a:p>
@@ -4786,7 +4786,7 @@
                   <a:schemeClr val="accent6"/>
                 </a:solidFill>
               </a:rPr>
-              <a:t>1. Solicitar la VM DEV (8 vCPU / 16 GB / 80 GB) · 2. Desplegar y repetir 22/22 y 27/27 en DEV · 3. Abrir acceso de softphones · 4. Iniciar FEAT-03 y FEAT-04</a:t>
+              <a:t>1. Publicar la rama con la cuenta con permisos · 2. Pedir jumbo frames en la red DEV (G3) · 3. Abrir acceso de softphones externos · 4. Iniciar FEAT-03 y FEAT-04</a:t>
             </a:r>
             <a:endParaRPr lang="en-US" sz="2000" dirty="0"/>
           </a:p>
@@ -4951,7 +4951,7 @@
                   <a:schemeClr val="tx1"/>
                 </a:solidFill>
               </a:rPr>
-              <a:t>reglas 3GPP en la captura final</a:t>
+              <a:t>reglas 3GPP en la captura local</a:t>
             </a:r>
             <a:endParaRPr lang="en-US" sz="1600" dirty="0"/>
           </a:p>
@@ -4987,7 +4987,7 @@
                   <a:schemeClr val="accent5"/>
                 </a:solidFill>
               </a:rPr>
-              <a:t>línea base: 5/27 (18,5 %)</a:t>
+              <a:t>DEV (Swarm): 27/28, solo falta G3 (MTU)</a:t>
             </a:r>
             <a:endParaRPr lang="en-US" sz="1200" dirty="0"/>
           </a:p>
@@ -5089,7 +5089,7 @@
                   <a:schemeClr val="tx1"/>
                 </a:solidFill>
               </a:rPr>
-              <a:t>checks E2E del test de la maqueta</a:t>
+              <a:t>checks E2E del contrato, también en DEV</a:t>
             </a:r>
             <a:endParaRPr lang="en-US" sz="1600" dirty="0"/>
           </a:p>
@@ -5125,7 +5125,7 @@
                   <a:schemeClr val="accent5"/>
                 </a:solidFill>
               </a:rPr>
-              <a:t>antes: 16/20</a:t>
+              <a:t>UI web de DEV: 14/14</a:t>
             </a:r>
             <a:endParaRPr lang="en-US" sz="1200" dirty="0"/>
           </a:p>
@@ -5191,7 +5191,7 @@
                 <a:ea typeface="Cambria" pitchFamily="34" charset="-122"/>
                 <a:cs typeface="Cambria" pitchFamily="34" charset="-120"/>
               </a:rPr>
-              <a:t>103</a:t>
+              <a:t>97</a:t>
             </a:r>
             <a:endParaRPr lang="en-US" sz="6000" dirty="0"/>
           </a:p>
@@ -5227,7 +5227,7 @@
                   <a:schemeClr val="tx1"/>
                 </a:solidFill>
               </a:rPr>
-              <a:t>paquetes ESP con integridad verificada</a:t>
+              <a:t>paquetes ESP con integridad verificada en DEV</a:t>
             </a:r>
             <a:endParaRPr lang="en-US" sz="1600" dirty="0"/>
           </a:p>
@@ -5299,7 +5299,7 @@
                   <a:schemeClr val="tx1"/>
                 </a:solidFill>
               </a:rPr>
-              <a:t>Verificado en 29 iteraciones de captura (tcpdump → tshark -Y sip → check_3gpp.py); dos corridas finales consecutivas al 100 %.</a:t>
+              <a:t>Local: 29 iteraciones de captura (tcpdump → tshark -Y sip → check_3gpp.py). DEV: 11 correcciones de despliegue y 2 iteraciones de captura sobre los 3 nodos.</a:t>
             </a:r>
             <a:endParaRPr lang="en-US" sz="1600" dirty="0"/>
           </a:p>
@@ -10174,7 +10174,7 @@
         </p:nvSpPr>
         <p:spPr>
           <a:xfrm>
-            <a:off x="4846320" y="1280160"/>
+            <a:off x="5047488" y="1280160"/>
             <a:ext cx="548640" cy="274320"/>
           </a:xfrm>
           <a:prstGeom prst="rect">
@@ -10210,7 +10210,7 @@
         </p:nvSpPr>
         <p:spPr>
           <a:xfrm>
-            <a:off x="5852160" y="1280160"/>
+            <a:off x="6254496" y="1280160"/>
             <a:ext cx="548640" cy="274320"/>
           </a:xfrm>
           <a:prstGeom prst="rect">
@@ -10246,7 +10246,7 @@
         </p:nvSpPr>
         <p:spPr>
           <a:xfrm>
-            <a:off x="6858000" y="1280160"/>
+            <a:off x="7461504" y="1280160"/>
             <a:ext cx="548640" cy="274320"/>
           </a:xfrm>
           <a:prstGeom prst="rect">
@@ -10282,7 +10282,7 @@
         </p:nvSpPr>
         <p:spPr>
           <a:xfrm>
-            <a:off x="7863840" y="1280160"/>
+            <a:off x="8668512" y="1280160"/>
             <a:ext cx="548640" cy="274320"/>
           </a:xfrm>
           <a:prstGeom prst="rect">
@@ -10318,7 +10318,7 @@
         </p:nvSpPr>
         <p:spPr>
           <a:xfrm>
-            <a:off x="8869680" y="1280160"/>
+            <a:off x="9875520" y="1280160"/>
             <a:ext cx="548640" cy="274320"/>
           </a:xfrm>
           <a:prstGeom prst="rect">
@@ -10354,8 +10354,8 @@
         </p:nvSpPr>
         <p:spPr>
           <a:xfrm>
-            <a:off x="9875520" y="1280160"/>
-            <a:ext cx="548640" cy="274320"/>
+            <a:off x="548640" y="1645920"/>
+            <a:ext cx="3383280" cy="420624"/>
           </a:xfrm>
           <a:prstGeom prst="rect">
             <a:avLst/>
@@ -10371,48 +10371,12 @@
               <a:buNone/>
             </a:pPr>
             <a:r>
-              <a:rPr lang="en-US" sz="1000" dirty="0">
-                <a:solidFill>
-                  <a:schemeClr val="accent5"/>
-                </a:solidFill>
-              </a:rPr>
-              <a:t>S7</a:t>
-            </a:r>
-            <a:endParaRPr lang="en-US" sz="1000" dirty="0"/>
-          </a:p>
-        </p:txBody>
-      </p:sp>
-      <p:sp>
-        <p:nvSpPr>
-          <p:cNvPr id="10" name="Text 8"/>
-          <p:cNvSpPr txBox="1"/>
-          <p:nvPr/>
-        </p:nvSpPr>
-        <p:spPr>
-          <a:xfrm>
-            <a:off x="548640" y="1645920"/>
-            <a:ext cx="3383280" cy="420624"/>
-          </a:xfrm>
-          <a:prstGeom prst="rect">
-            <a:avLst/>
-          </a:prstGeom>
-          <a:noFill/>
-          <a:ln/>
-        </p:spPr>
-        <p:txBody>
-          <a:bodyPr wrap="square" lIns="0" tIns="0" rIns="0" bIns="0" rtlCol="0" anchor="ctr"/>
-          <a:lstStyle/>
-          <a:p>
-            <a:pPr indent="0" marL="0">
-              <a:buNone/>
-            </a:pPr>
-            <a:r>
               <a:rPr lang="en-US" sz="1300" dirty="0">
                 <a:solidFill>
                   <a:schemeClr val="tx1"/>
                 </a:solidFill>
               </a:rPr>
-              <a:t>Solicitud y provisión de VM DEV</a:t>
+              <a:t>Provisión de 3 VM DEV (hecho)</a:t>
             </a:r>
             <a:endParaRPr lang="en-US" sz="1300" dirty="0"/>
           </a:p>
@@ -10420,18 +10384,18 @@
       </p:sp>
       <p:sp>
         <p:nvSpPr>
-          <p:cNvPr id="11" name="barra-0"/>
+          <p:cNvPr id="10" name="barra-0"/>
           <p:cNvSpPr/>
           <p:nvPr/>
         </p:nvSpPr>
         <p:spPr>
           <a:xfrm>
             <a:off x="3840480" y="1700784"/>
-            <a:ext cx="1005840" cy="310896"/>
+            <a:ext cx="72420" cy="310896"/>
           </a:xfrm>
           <a:prstGeom prst="roundRect">
             <a:avLst>
-              <a:gd name="adj" fmla="val 17647"/>
+              <a:gd name="adj" fmla="val 75758"/>
             </a:avLst>
           </a:prstGeom>
           <a:solidFill>
@@ -10447,14 +10411,50 @@
       </p:sp>
       <p:sp>
         <p:nvSpPr>
+          <p:cNvPr id="11" name="Text 9"/>
+          <p:cNvSpPr txBox="1"/>
+          <p:nvPr/>
+        </p:nvSpPr>
+        <p:spPr>
+          <a:xfrm>
+            <a:off x="3913632" y="1645920"/>
+            <a:ext cx="2011680" cy="420624"/>
+          </a:xfrm>
+          <a:prstGeom prst="rect">
+            <a:avLst/>
+          </a:prstGeom>
+          <a:noFill/>
+          <a:ln/>
+        </p:spPr>
+        <p:txBody>
+          <a:bodyPr wrap="square" lIns="0" tIns="0" rIns="0" bIns="0" rtlCol="0" anchor="ctr"/>
+          <a:lstStyle/>
+          <a:p>
+            <a:pPr indent="0" marL="0">
+              <a:buNone/>
+            </a:pPr>
+            <a:r>
+              <a:rPr lang="en-US" sz="1000" dirty="0">
+                <a:solidFill>
+                  <a:schemeClr val="accent5"/>
+                </a:solidFill>
+              </a:rPr>
+              <a:t>12 de oct – 12 de oct</a:t>
+            </a:r>
+            <a:endParaRPr lang="en-US" sz="1000" dirty="0"/>
+          </a:p>
+        </p:txBody>
+      </p:sp>
+      <p:sp>
+        <p:nvSpPr>
           <p:cNvPr id="12" name="Text 10"/>
           <p:cNvSpPr txBox="1"/>
           <p:nvPr/>
         </p:nvSpPr>
         <p:spPr>
           <a:xfrm>
-            <a:off x="4919472" y="1645920"/>
-            <a:ext cx="2011680" cy="420624"/>
+            <a:off x="548640" y="2139696"/>
+            <a:ext cx="3383280" cy="420624"/>
           </a:xfrm>
           <a:prstGeom prst="rect">
             <a:avLst/>
@@ -10470,48 +10470,12 @@
               <a:buNone/>
             </a:pPr>
             <a:r>
-              <a:rPr lang="en-US" sz="1000" dirty="0">
-                <a:solidFill>
-                  <a:schemeClr val="accent5"/>
-                </a:solidFill>
-              </a:rPr>
-              <a:t>12 de oct – 16 de oct</a:t>
-            </a:r>
-            <a:endParaRPr lang="en-US" sz="1000" dirty="0"/>
-          </a:p>
-        </p:txBody>
-      </p:sp>
-      <p:sp>
-        <p:nvSpPr>
-          <p:cNvPr id="13" name="Text 11"/>
-          <p:cNvSpPr txBox="1"/>
-          <p:nvPr/>
-        </p:nvSpPr>
-        <p:spPr>
-          <a:xfrm>
-            <a:off x="548640" y="2139696"/>
-            <a:ext cx="3383280" cy="420624"/>
-          </a:xfrm>
-          <a:prstGeom prst="rect">
-            <a:avLst/>
-          </a:prstGeom>
-          <a:noFill/>
-          <a:ln/>
-        </p:spPr>
-        <p:txBody>
-          <a:bodyPr wrap="square" lIns="0" tIns="0" rIns="0" bIns="0" rtlCol="0" anchor="ctr"/>
-          <a:lstStyle/>
-          <a:p>
-            <a:pPr indent="0" marL="0">
-              <a:buNone/>
-            </a:pPr>
-            <a:r>
               <a:rPr lang="en-US" sz="1300" dirty="0">
                 <a:solidFill>
                   <a:schemeClr val="tx1"/>
                 </a:solidFill>
               </a:rPr>
-              <a:t>Despliegue maqueta + E2E 22/22 en DEV</a:t>
+              <a:t>Swarm + E2E 22/22 en DEV (hecho)</a:t>
             </a:r>
             <a:endParaRPr lang="en-US" sz="1300" dirty="0"/>
           </a:p>
@@ -10519,14 +10483,14 @@
       </p:sp>
       <p:sp>
         <p:nvSpPr>
-          <p:cNvPr id="14" name="barra-1"/>
+          <p:cNvPr id="13" name="barra-1"/>
           <p:cNvSpPr/>
           <p:nvPr/>
         </p:nvSpPr>
         <p:spPr>
           <a:xfrm>
-            <a:off x="4846320" y="2194560"/>
-            <a:ext cx="603504" cy="310896"/>
+            <a:off x="3840480" y="2194560"/>
+            <a:ext cx="724205" cy="310896"/>
           </a:xfrm>
           <a:prstGeom prst="roundRect">
             <a:avLst>
@@ -10546,14 +10510,50 @@
       </p:sp>
       <p:sp>
         <p:nvSpPr>
+          <p:cNvPr id="14" name="Text 12"/>
+          <p:cNvSpPr txBox="1"/>
+          <p:nvPr/>
+        </p:nvSpPr>
+        <p:spPr>
+          <a:xfrm>
+            <a:off x="4637837" y="2139696"/>
+            <a:ext cx="2011680" cy="420624"/>
+          </a:xfrm>
+          <a:prstGeom prst="rect">
+            <a:avLst/>
+          </a:prstGeom>
+          <a:noFill/>
+          <a:ln/>
+        </p:spPr>
+        <p:txBody>
+          <a:bodyPr wrap="square" lIns="0" tIns="0" rIns="0" bIns="0" rtlCol="0" anchor="ctr"/>
+          <a:lstStyle/>
+          <a:p>
+            <a:pPr indent="0" marL="0">
+              <a:buNone/>
+            </a:pPr>
+            <a:r>
+              <a:rPr lang="en-US" sz="1000" dirty="0">
+                <a:solidFill>
+                  <a:schemeClr val="accent5"/>
+                </a:solidFill>
+              </a:rPr>
+              <a:t>12 de oct – 14 de oct</a:t>
+            </a:r>
+            <a:endParaRPr lang="en-US" sz="1000" dirty="0"/>
+          </a:p>
+        </p:txBody>
+      </p:sp>
+      <p:sp>
+        <p:nvSpPr>
           <p:cNvPr id="15" name="Text 13"/>
           <p:cNvSpPr txBox="1"/>
           <p:nvPr/>
         </p:nvSpPr>
         <p:spPr>
           <a:xfrm>
-            <a:off x="5522976" y="2139696"/>
-            <a:ext cx="2011680" cy="420624"/>
+            <a:off x="548640" y="2633472"/>
+            <a:ext cx="3383280" cy="420624"/>
           </a:xfrm>
           <a:prstGeom prst="rect">
             <a:avLst/>
@@ -10569,42 +10569,6 @@
               <a:buNone/>
             </a:pPr>
             <a:r>
-              <a:rPr lang="en-US" sz="1000" dirty="0">
-                <a:solidFill>
-                  <a:schemeClr val="accent5"/>
-                </a:solidFill>
-              </a:rPr>
-              <a:t>19 de oct – 21 de oct</a:t>
-            </a:r>
-            <a:endParaRPr lang="en-US" sz="1000" dirty="0"/>
-          </a:p>
-        </p:txBody>
-      </p:sp>
-      <p:sp>
-        <p:nvSpPr>
-          <p:cNvPr id="16" name="Text 14"/>
-          <p:cNvSpPr txBox="1"/>
-          <p:nvPr/>
-        </p:nvSpPr>
-        <p:spPr>
-          <a:xfrm>
-            <a:off x="548640" y="2633472"/>
-            <a:ext cx="3383280" cy="420624"/>
-          </a:xfrm>
-          <a:prstGeom prst="rect">
-            <a:avLst/>
-          </a:prstGeom>
-          <a:noFill/>
-          <a:ln/>
-        </p:spPr>
-        <p:txBody>
-          <a:bodyPr wrap="square" lIns="0" tIns="0" rIns="0" bIns="0" rtlCol="0" anchor="ctr"/>
-          <a:lstStyle/>
-          <a:p>
-            <a:pPr indent="0" marL="0">
-              <a:buNone/>
-            </a:pPr>
-            <a:r>
               <a:rPr lang="en-US" sz="1300" dirty="0">
                 <a:solidFill>
                   <a:schemeClr val="tx1"/>
@@ -10618,14 +10582,14 @@
       </p:sp>
       <p:sp>
         <p:nvSpPr>
-          <p:cNvPr id="17" name="barra-2"/>
+          <p:cNvPr id="16" name="barra-2"/>
           <p:cNvSpPr/>
           <p:nvPr/>
         </p:nvSpPr>
         <p:spPr>
           <a:xfrm>
-            <a:off x="5449824" y="2688336"/>
-            <a:ext cx="603504" cy="310896"/>
+            <a:off x="4564685" y="2688336"/>
+            <a:ext cx="724205" cy="310896"/>
           </a:xfrm>
           <a:prstGeom prst="roundRect">
             <a:avLst>
@@ -10645,14 +10609,50 @@
       </p:sp>
       <p:sp>
         <p:nvSpPr>
+          <p:cNvPr id="17" name="Text 15"/>
+          <p:cNvSpPr txBox="1"/>
+          <p:nvPr/>
+        </p:nvSpPr>
+        <p:spPr>
+          <a:xfrm>
+            <a:off x="5362042" y="2633472"/>
+            <a:ext cx="2011680" cy="420624"/>
+          </a:xfrm>
+          <a:prstGeom prst="rect">
+            <a:avLst/>
+          </a:prstGeom>
+          <a:noFill/>
+          <a:ln/>
+        </p:spPr>
+        <p:txBody>
+          <a:bodyPr wrap="square" lIns="0" tIns="0" rIns="0" bIns="0" rtlCol="0" anchor="ctr"/>
+          <a:lstStyle/>
+          <a:p>
+            <a:pPr indent="0" marL="0">
+              <a:buNone/>
+            </a:pPr>
+            <a:r>
+              <a:rPr lang="en-US" sz="1000" dirty="0">
+                <a:solidFill>
+                  <a:schemeClr val="accent5"/>
+                </a:solidFill>
+              </a:rPr>
+              <a:t>15 de oct – 19 de oct</a:t>
+            </a:r>
+            <a:endParaRPr lang="en-US" sz="1000" dirty="0"/>
+          </a:p>
+        </p:txBody>
+      </p:sp>
+      <p:sp>
+        <p:nvSpPr>
           <p:cNvPr id="18" name="Text 16"/>
           <p:cNvSpPr txBox="1"/>
           <p:nvPr/>
         </p:nvSpPr>
         <p:spPr>
           <a:xfrm>
-            <a:off x="6126480" y="2633472"/>
-            <a:ext cx="2011680" cy="420624"/>
+            <a:off x="548640" y="3127248"/>
+            <a:ext cx="3383280" cy="420624"/>
           </a:xfrm>
           <a:prstGeom prst="rect">
             <a:avLst/>
@@ -10668,42 +10668,6 @@
               <a:buNone/>
             </a:pPr>
             <a:r>
-              <a:rPr lang="en-US" sz="1000" dirty="0">
-                <a:solidFill>
-                  <a:schemeClr val="accent5"/>
-                </a:solidFill>
-              </a:rPr>
-              <a:t>22 de oct – 26 de oct</a:t>
-            </a:r>
-            <a:endParaRPr lang="en-US" sz="1000" dirty="0"/>
-          </a:p>
-        </p:txBody>
-      </p:sp>
-      <p:sp>
-        <p:nvSpPr>
-          <p:cNvPr id="19" name="Text 17"/>
-          <p:cNvSpPr txBox="1"/>
-          <p:nvPr/>
-        </p:nvSpPr>
-        <p:spPr>
-          <a:xfrm>
-            <a:off x="548640" y="3127248"/>
-            <a:ext cx="3383280" cy="420624"/>
-          </a:xfrm>
-          <a:prstGeom prst="rect">
-            <a:avLst/>
-          </a:prstGeom>
-          <a:noFill/>
-          <a:ln/>
-        </p:spPr>
-        <p:txBody>
-          <a:bodyPr wrap="square" lIns="0" tIns="0" rIns="0" bIns="0" rtlCol="0" anchor="ctr"/>
-          <a:lstStyle/>
-          <a:p>
-            <a:pPr indent="0" marL="0">
-              <a:buNone/>
-            </a:pPr>
-            <a:r>
               <a:rPr lang="en-US" sz="1300" dirty="0">
                 <a:solidFill>
                   <a:schemeClr val="tx1"/>
@@ -10717,14 +10681,14 @@
       </p:sp>
       <p:sp>
         <p:nvSpPr>
-          <p:cNvPr id="20" name="barra-3"/>
+          <p:cNvPr id="19" name="barra-3"/>
           <p:cNvSpPr/>
           <p:nvPr/>
         </p:nvSpPr>
         <p:spPr>
           <a:xfrm>
-            <a:off x="5449824" y="3182112"/>
-            <a:ext cx="1609344" cy="310896"/>
+            <a:off x="4564685" y="3182112"/>
+            <a:ext cx="1931213" cy="310896"/>
           </a:xfrm>
           <a:prstGeom prst="roundRect">
             <a:avLst>
@@ -10744,14 +10708,50 @@
       </p:sp>
       <p:sp>
         <p:nvSpPr>
+          <p:cNvPr id="20" name="Text 18"/>
+          <p:cNvSpPr txBox="1"/>
+          <p:nvPr/>
+        </p:nvSpPr>
+        <p:spPr>
+          <a:xfrm>
+            <a:off x="6569050" y="3127248"/>
+            <a:ext cx="2011680" cy="420624"/>
+          </a:xfrm>
+          <a:prstGeom prst="rect">
+            <a:avLst/>
+          </a:prstGeom>
+          <a:noFill/>
+          <a:ln/>
+        </p:spPr>
+        <p:txBody>
+          <a:bodyPr wrap="square" lIns="0" tIns="0" rIns="0" bIns="0" rtlCol="0" anchor="ctr"/>
+          <a:lstStyle/>
+          <a:p>
+            <a:pPr indent="0" marL="0">
+              <a:buNone/>
+            </a:pPr>
+            <a:r>
+              <a:rPr lang="en-US" sz="1000" dirty="0">
+                <a:solidFill>
+                  <a:schemeClr val="accent5"/>
+                </a:solidFill>
+              </a:rPr>
+              <a:t>15 de oct – 26 de oct</a:t>
+            </a:r>
+            <a:endParaRPr lang="en-US" sz="1000" dirty="0"/>
+          </a:p>
+        </p:txBody>
+      </p:sp>
+      <p:sp>
+        <p:nvSpPr>
           <p:cNvPr id="21" name="Text 19"/>
           <p:cNvSpPr txBox="1"/>
           <p:nvPr/>
         </p:nvSpPr>
         <p:spPr>
           <a:xfrm>
-            <a:off x="7132320" y="3127248"/>
-            <a:ext cx="2011680" cy="420624"/>
+            <a:off x="548640" y="3621024"/>
+            <a:ext cx="3383280" cy="420624"/>
           </a:xfrm>
           <a:prstGeom prst="rect">
             <a:avLst/>
@@ -10767,42 +10767,6 @@
               <a:buNone/>
             </a:pPr>
             <a:r>
-              <a:rPr lang="en-US" sz="1000" dirty="0">
-                <a:solidFill>
-                  <a:schemeClr val="accent5"/>
-                </a:solidFill>
-              </a:rPr>
-              <a:t>22 de oct – 2 de nov</a:t>
-            </a:r>
-            <a:endParaRPr lang="en-US" sz="1000" dirty="0"/>
-          </a:p>
-        </p:txBody>
-      </p:sp>
-      <p:sp>
-        <p:nvSpPr>
-          <p:cNvPr id="22" name="Text 20"/>
-          <p:cNvSpPr txBox="1"/>
-          <p:nvPr/>
-        </p:nvSpPr>
-        <p:spPr>
-          <a:xfrm>
-            <a:off x="548640" y="3621024"/>
-            <a:ext cx="3383280" cy="420624"/>
-          </a:xfrm>
-          <a:prstGeom prst="rect">
-            <a:avLst/>
-          </a:prstGeom>
-          <a:noFill/>
-          <a:ln/>
-        </p:spPr>
-        <p:txBody>
-          <a:bodyPr wrap="square" lIns="0" tIns="0" rIns="0" bIns="0" rtlCol="0" anchor="ctr"/>
-          <a:lstStyle/>
-          <a:p>
-            <a:pPr indent="0" marL="0">
-              <a:buNone/>
-            </a:pPr>
-            <a:r>
               <a:rPr lang="en-US" sz="1300" dirty="0">
                 <a:solidFill>
                   <a:schemeClr val="tx1"/>
@@ -10816,14 +10780,14 @@
       </p:sp>
       <p:sp>
         <p:nvSpPr>
-          <p:cNvPr id="23" name="barra-4"/>
+          <p:cNvPr id="22" name="barra-4"/>
           <p:cNvSpPr/>
           <p:nvPr/>
         </p:nvSpPr>
         <p:spPr>
           <a:xfrm>
-            <a:off x="7059168" y="3675888"/>
-            <a:ext cx="1005840" cy="310896"/>
+            <a:off x="6495898" y="3675888"/>
+            <a:ext cx="1207008" cy="310896"/>
           </a:xfrm>
           <a:prstGeom prst="roundRect">
             <a:avLst>
@@ -10843,14 +10807,50 @@
       </p:sp>
       <p:sp>
         <p:nvSpPr>
+          <p:cNvPr id="23" name="Text 21"/>
+          <p:cNvSpPr txBox="1"/>
+          <p:nvPr/>
+        </p:nvSpPr>
+        <p:spPr>
+          <a:xfrm>
+            <a:off x="7776058" y="3621024"/>
+            <a:ext cx="2011680" cy="420624"/>
+          </a:xfrm>
+          <a:prstGeom prst="rect">
+            <a:avLst/>
+          </a:prstGeom>
+          <a:noFill/>
+          <a:ln/>
+        </p:spPr>
+        <p:txBody>
+          <a:bodyPr wrap="square" lIns="0" tIns="0" rIns="0" bIns="0" rtlCol="0" anchor="ctr"/>
+          <a:lstStyle/>
+          <a:p>
+            <a:pPr indent="0" marL="0">
+              <a:buNone/>
+            </a:pPr>
+            <a:r>
+              <a:rPr lang="en-US" sz="1000" dirty="0">
+                <a:solidFill>
+                  <a:schemeClr val="accent5"/>
+                </a:solidFill>
+              </a:rPr>
+              <a:t>27 de oct – 2 de nov</a:t>
+            </a:r>
+            <a:endParaRPr lang="en-US" sz="1000" dirty="0"/>
+          </a:p>
+        </p:txBody>
+      </p:sp>
+      <p:sp>
+        <p:nvSpPr>
           <p:cNvPr id="24" name="Text 22"/>
           <p:cNvSpPr txBox="1"/>
           <p:nvPr/>
         </p:nvSpPr>
         <p:spPr>
           <a:xfrm>
-            <a:off x="8138160" y="3621024"/>
-            <a:ext cx="2011680" cy="420624"/>
+            <a:off x="548640" y="4114800"/>
+            <a:ext cx="3383280" cy="420624"/>
           </a:xfrm>
           <a:prstGeom prst="rect">
             <a:avLst/>
@@ -10866,42 +10866,6 @@
               <a:buNone/>
             </a:pPr>
             <a:r>
-              <a:rPr lang="en-US" sz="1000" dirty="0">
-                <a:solidFill>
-                  <a:schemeClr val="accent5"/>
-                </a:solidFill>
-              </a:rPr>
-              <a:t>3 de nov – 9 de nov</a:t>
-            </a:r>
-            <a:endParaRPr lang="en-US" sz="1000" dirty="0"/>
-          </a:p>
-        </p:txBody>
-      </p:sp>
-      <p:sp>
-        <p:nvSpPr>
-          <p:cNvPr id="25" name="Text 23"/>
-          <p:cNvSpPr txBox="1"/>
-          <p:nvPr/>
-        </p:nvSpPr>
-        <p:spPr>
-          <a:xfrm>
-            <a:off x="548640" y="4114800"/>
-            <a:ext cx="3383280" cy="420624"/>
-          </a:xfrm>
-          <a:prstGeom prst="rect">
-            <a:avLst/>
-          </a:prstGeom>
-          <a:noFill/>
-          <a:ln/>
-        </p:spPr>
-        <p:txBody>
-          <a:bodyPr wrap="square" lIns="0" tIns="0" rIns="0" bIns="0" rtlCol="0" anchor="ctr"/>
-          <a:lstStyle/>
-          <a:p>
-            <a:pPr indent="0" marL="0">
-              <a:buNone/>
-            </a:pPr>
-            <a:r>
               <a:rPr lang="en-US" sz="1300" dirty="0">
                 <a:solidFill>
                   <a:schemeClr val="tx1"/>
@@ -10915,14 +10879,14 @@
       </p:sp>
       <p:sp>
         <p:nvSpPr>
-          <p:cNvPr id="26" name="barra-5"/>
+          <p:cNvPr id="25" name="barra-5"/>
           <p:cNvSpPr/>
           <p:nvPr/>
         </p:nvSpPr>
         <p:spPr>
           <a:xfrm>
-            <a:off x="7059168" y="4169664"/>
-            <a:ext cx="1005840" cy="310896"/>
+            <a:off x="6495898" y="4169664"/>
+            <a:ext cx="1207008" cy="310896"/>
           </a:xfrm>
           <a:prstGeom prst="roundRect">
             <a:avLst>
@@ -10942,14 +10906,50 @@
       </p:sp>
       <p:sp>
         <p:nvSpPr>
+          <p:cNvPr id="26" name="Text 24"/>
+          <p:cNvSpPr txBox="1"/>
+          <p:nvPr/>
+        </p:nvSpPr>
+        <p:spPr>
+          <a:xfrm>
+            <a:off x="7776058" y="4114800"/>
+            <a:ext cx="2011680" cy="420624"/>
+          </a:xfrm>
+          <a:prstGeom prst="rect">
+            <a:avLst/>
+          </a:prstGeom>
+          <a:noFill/>
+          <a:ln/>
+        </p:spPr>
+        <p:txBody>
+          <a:bodyPr wrap="square" lIns="0" tIns="0" rIns="0" bIns="0" rtlCol="0" anchor="ctr"/>
+          <a:lstStyle/>
+          <a:p>
+            <a:pPr indent="0" marL="0">
+              <a:buNone/>
+            </a:pPr>
+            <a:r>
+              <a:rPr lang="en-US" sz="1000" dirty="0">
+                <a:solidFill>
+                  <a:schemeClr val="accent5"/>
+                </a:solidFill>
+              </a:rPr>
+              <a:t>27 de oct – 2 de nov</a:t>
+            </a:r>
+            <a:endParaRPr lang="en-US" sz="1000" dirty="0"/>
+          </a:p>
+        </p:txBody>
+      </p:sp>
+      <p:sp>
+        <p:nvSpPr>
           <p:cNvPr id="27" name="Text 25"/>
           <p:cNvSpPr txBox="1"/>
           <p:nvPr/>
         </p:nvSpPr>
         <p:spPr>
           <a:xfrm>
-            <a:off x="8138160" y="4114800"/>
-            <a:ext cx="2011680" cy="420624"/>
+            <a:off x="548640" y="4608576"/>
+            <a:ext cx="3383280" cy="420624"/>
           </a:xfrm>
           <a:prstGeom prst="rect">
             <a:avLst/>
@@ -10965,42 +10965,6 @@
               <a:buNone/>
             </a:pPr>
             <a:r>
-              <a:rPr lang="en-US" sz="1000" dirty="0">
-                <a:solidFill>
-                  <a:schemeClr val="accent5"/>
-                </a:solidFill>
-              </a:rPr>
-              <a:t>3 de nov – 9 de nov</a:t>
-            </a:r>
-            <a:endParaRPr lang="en-US" sz="1000" dirty="0"/>
-          </a:p>
-        </p:txBody>
-      </p:sp>
-      <p:sp>
-        <p:nvSpPr>
-          <p:cNvPr id="28" name="Text 26"/>
-          <p:cNvSpPr txBox="1"/>
-          <p:nvPr/>
-        </p:nvSpPr>
-        <p:spPr>
-          <a:xfrm>
-            <a:off x="548640" y="4608576"/>
-            <a:ext cx="3383280" cy="420624"/>
-          </a:xfrm>
-          <a:prstGeom prst="rect">
-            <a:avLst/>
-          </a:prstGeom>
-          <a:noFill/>
-          <a:ln/>
-        </p:spPr>
-        <p:txBody>
-          <a:bodyPr wrap="square" lIns="0" tIns="0" rIns="0" bIns="0" rtlCol="0" anchor="ctr"/>
-          <a:lstStyle/>
-          <a:p>
-            <a:pPr indent="0" marL="0">
-              <a:buNone/>
-            </a:pPr>
-            <a:r>
               <a:rPr lang="en-US" sz="1300" dirty="0">
                 <a:solidFill>
                   <a:schemeClr val="tx1"/>
@@ -11014,14 +10978,14 @@
       </p:sp>
       <p:sp>
         <p:nvSpPr>
-          <p:cNvPr id="29" name="barra-6"/>
+          <p:cNvPr id="28" name="barra-6"/>
           <p:cNvSpPr/>
           <p:nvPr/>
         </p:nvSpPr>
         <p:spPr>
           <a:xfrm>
-            <a:off x="8065008" y="4663440"/>
-            <a:ext cx="1005840" cy="310896"/>
+            <a:off x="7702906" y="4663440"/>
+            <a:ext cx="1207008" cy="310896"/>
           </a:xfrm>
           <a:prstGeom prst="roundRect">
             <a:avLst>
@@ -11041,14 +11005,50 @@
       </p:sp>
       <p:sp>
         <p:nvSpPr>
+          <p:cNvPr id="29" name="Text 27"/>
+          <p:cNvSpPr txBox="1"/>
+          <p:nvPr/>
+        </p:nvSpPr>
+        <p:spPr>
+          <a:xfrm>
+            <a:off x="8983066" y="4608576"/>
+            <a:ext cx="2011680" cy="420624"/>
+          </a:xfrm>
+          <a:prstGeom prst="rect">
+            <a:avLst/>
+          </a:prstGeom>
+          <a:noFill/>
+          <a:ln/>
+        </p:spPr>
+        <p:txBody>
+          <a:bodyPr wrap="square" lIns="0" tIns="0" rIns="0" bIns="0" rtlCol="0" anchor="ctr"/>
+          <a:lstStyle/>
+          <a:p>
+            <a:pPr indent="0" marL="0">
+              <a:buNone/>
+            </a:pPr>
+            <a:r>
+              <a:rPr lang="en-US" sz="1000" dirty="0">
+                <a:solidFill>
+                  <a:schemeClr val="accent5"/>
+                </a:solidFill>
+              </a:rPr>
+              <a:t>3 de nov – 9 de nov</a:t>
+            </a:r>
+            <a:endParaRPr lang="en-US" sz="1000" dirty="0"/>
+          </a:p>
+        </p:txBody>
+      </p:sp>
+      <p:sp>
+        <p:nvSpPr>
           <p:cNvPr id="30" name="Text 28"/>
           <p:cNvSpPr txBox="1"/>
           <p:nvPr/>
         </p:nvSpPr>
         <p:spPr>
           <a:xfrm>
-            <a:off x="9144000" y="4608576"/>
-            <a:ext cx="2011680" cy="420624"/>
+            <a:off x="548640" y="5102352"/>
+            <a:ext cx="3383280" cy="420624"/>
           </a:xfrm>
           <a:prstGeom prst="rect">
             <a:avLst/>
@@ -11064,42 +11064,6 @@
               <a:buNone/>
             </a:pPr>
             <a:r>
-              <a:rPr lang="en-US" sz="1000" dirty="0">
-                <a:solidFill>
-                  <a:schemeClr val="accent5"/>
-                </a:solidFill>
-              </a:rPr>
-              <a:t>10 de nov – 16 de nov</a:t>
-            </a:r>
-            <a:endParaRPr lang="en-US" sz="1000" dirty="0"/>
-          </a:p>
-        </p:txBody>
-      </p:sp>
-      <p:sp>
-        <p:nvSpPr>
-          <p:cNvPr id="31" name="Text 29"/>
-          <p:cNvSpPr txBox="1"/>
-          <p:nvPr/>
-        </p:nvSpPr>
-        <p:spPr>
-          <a:xfrm>
-            <a:off x="548640" y="5102352"/>
-            <a:ext cx="3383280" cy="420624"/>
-          </a:xfrm>
-          <a:prstGeom prst="rect">
-            <a:avLst/>
-          </a:prstGeom>
-          <a:noFill/>
-          <a:ln/>
-        </p:spPr>
-        <p:txBody>
-          <a:bodyPr wrap="square" lIns="0" tIns="0" rIns="0" bIns="0" rtlCol="0" anchor="ctr"/>
-          <a:lstStyle/>
-          <a:p>
-            <a:pPr indent="0" marL="0">
-              <a:buNone/>
-            </a:pPr>
-            <a:r>
               <a:rPr lang="en-US" sz="1300" dirty="0">
                 <a:solidFill>
                   <a:schemeClr val="tx1"/>
@@ -11113,14 +11077,14 @@
       </p:sp>
       <p:sp>
         <p:nvSpPr>
-          <p:cNvPr id="32" name="barra-7"/>
+          <p:cNvPr id="31" name="barra-7"/>
           <p:cNvSpPr/>
           <p:nvPr/>
         </p:nvSpPr>
         <p:spPr>
           <a:xfrm>
-            <a:off x="9070848" y="5157216"/>
-            <a:ext cx="804672" cy="310896"/>
+            <a:off x="8909914" y="5157216"/>
+            <a:ext cx="965606" cy="310896"/>
           </a:xfrm>
           <a:prstGeom prst="roundRect">
             <a:avLst>
@@ -11140,14 +11104,50 @@
       </p:sp>
       <p:sp>
         <p:nvSpPr>
+          <p:cNvPr id="32" name="Text 30"/>
+          <p:cNvSpPr txBox="1"/>
+          <p:nvPr/>
+        </p:nvSpPr>
+        <p:spPr>
+          <a:xfrm>
+            <a:off x="9948672" y="5102352"/>
+            <a:ext cx="2011680" cy="420624"/>
+          </a:xfrm>
+          <a:prstGeom prst="rect">
+            <a:avLst/>
+          </a:prstGeom>
+          <a:noFill/>
+          <a:ln/>
+        </p:spPr>
+        <p:txBody>
+          <a:bodyPr wrap="square" lIns="0" tIns="0" rIns="0" bIns="0" rtlCol="0" anchor="ctr"/>
+          <a:lstStyle/>
+          <a:p>
+            <a:pPr indent="0" marL="0">
+              <a:buNone/>
+            </a:pPr>
+            <a:r>
+              <a:rPr lang="en-US" sz="1000" dirty="0">
+                <a:solidFill>
+                  <a:schemeClr val="accent5"/>
+                </a:solidFill>
+              </a:rPr>
+              <a:t>10 de nov – 13 de nov</a:t>
+            </a:r>
+            <a:endParaRPr lang="en-US" sz="1000" dirty="0"/>
+          </a:p>
+        </p:txBody>
+      </p:sp>
+      <p:sp>
+        <p:nvSpPr>
           <p:cNvPr id="33" name="Text 31"/>
           <p:cNvSpPr txBox="1"/>
           <p:nvPr/>
         </p:nvSpPr>
         <p:spPr>
           <a:xfrm>
-            <a:off x="9948672" y="5102352"/>
-            <a:ext cx="2011680" cy="420624"/>
+            <a:off x="548640" y="5806440"/>
+            <a:ext cx="11064240" cy="502920"/>
           </a:xfrm>
           <a:prstGeom prst="rect">
             <a:avLst/>
@@ -11156,55 +11156,19 @@
           <a:ln/>
         </p:spPr>
         <p:txBody>
-          <a:bodyPr wrap="square" lIns="0" tIns="0" rIns="0" bIns="0" rtlCol="0" anchor="ctr"/>
+          <a:bodyPr wrap="square" rtlCol="0" anchor="ctr"/>
           <a:lstStyle/>
           <a:p>
             <a:pPr indent="0" marL="0">
               <a:buNone/>
             </a:pPr>
             <a:r>
-              <a:rPr lang="en-US" sz="1000" dirty="0">
+              <a:rPr lang="en-US" sz="1300" i="1" dirty="0">
                 <a:solidFill>
                   <a:schemeClr val="accent5"/>
                 </a:solidFill>
               </a:rPr>
-              <a:t>17 de nov – 20 de nov</a:t>
-            </a:r>
-            <a:endParaRPr lang="en-US" sz="1000" dirty="0"/>
-          </a:p>
-        </p:txBody>
-      </p:sp>
-      <p:sp>
-        <p:nvSpPr>
-          <p:cNvPr id="34" name="Text 32"/>
-          <p:cNvSpPr txBox="1"/>
-          <p:nvPr/>
-        </p:nvSpPr>
-        <p:spPr>
-          <a:xfrm>
-            <a:off x="548640" y="5806440"/>
-            <a:ext cx="11064240" cy="502920"/>
-          </a:xfrm>
-          <a:prstGeom prst="rect">
-            <a:avLst/>
-          </a:prstGeom>
-          <a:noFill/>
-          <a:ln/>
-        </p:spPr>
-        <p:txBody>
-          <a:bodyPr wrap="square" rtlCol="0" anchor="ctr"/>
-          <a:lstStyle/>
-          <a:p>
-            <a:pPr indent="0" marL="0">
-              <a:buNone/>
-            </a:pPr>
-            <a:r>
-              <a:rPr lang="en-US" sz="1300" i="1" dirty="0">
-                <a:solidFill>
-                  <a:schemeClr val="accent5"/>
-                </a:solidFill>
-              </a:rPr>
-              <a:t>Duración total: 30 días hábiles (12 de oct → 20 de nov). Supuestos: VM entregada en 5 días; acceso externo y endurecimiento en paralelo; FEAT-03 y FEAT-04 en paralelo.</a:t>
+              <a:t>Duración total: 25 días hábiles (12 de oct → 13 de nov). Hecho: VM DEV entregadas y maqueta verificada en Swarm (12–14 oct). Supuestos: acceso externo y endurecimiento en paralelo; FEAT-03 y FEAT-04 en paralelo.</a:t>
             </a:r>
             <a:endParaRPr lang="en-US" sz="1300" dirty="0"/>
           </a:p>
@@ -11312,7 +11276,7 @@
                   <a:schemeClr val="tx2"/>
                 </a:solidFill>
               </a:rPr>
-              <a:t>Qué pedir a infraestructura</a:t>
+              <a:t>DEV desplegado en tres servidores con Docker Swarm</a:t>
             </a:r>
             <a:endParaRPr lang="en-US" sz="3000" dirty="0"/>
           </a:p>
@@ -11378,7 +11342,7 @@
                 <a:ea typeface="Cambria" pitchFamily="34" charset="-122"/>
                 <a:cs typeface="Cambria" pitchFamily="34" charset="-120"/>
               </a:rPr>
-              <a:t>8 vCPU</a:t>
+              <a:t>.231</a:t>
             </a:r>
             <a:endParaRPr lang="en-US" sz="3600" dirty="0"/>
           </a:p>
@@ -11414,7 +11378,7 @@
                   <a:schemeClr val="tx1"/>
                 </a:solidFill>
               </a:rPr>
-              <a:t>CPU recomendada (mínimo 4)</a:t>
+              <a:t>Core IMS: P/I/S-CSCF, AS-Front, DNS, RTPEngine (4 vCPU · 8 GB)</a:t>
             </a:r>
             <a:endParaRPr lang="en-US" sz="1400" dirty="0"/>
           </a:p>
@@ -11480,7 +11444,7 @@
                 <a:ea typeface="Cambria" pitchFamily="34" charset="-122"/>
                 <a:cs typeface="Cambria" pitchFamily="34" charset="-120"/>
               </a:rPr>
-              <a:t>16 GB</a:t>
+              <a:t>.232</a:t>
             </a:r>
             <a:endParaRPr lang="en-US" sz="3600" dirty="0"/>
           </a:p>
@@ -11516,7 +11480,7 @@
                   <a:schemeClr val="tx1"/>
                 </a:solidFill>
               </a:rPr>
-              <a:t>RAM recomendada (mínimo 8)</a:t>
+              <a:t>Base de datos: MySQL, Redis, PyHSS (2 vCPU · 4 GB)</a:t>
             </a:r>
             <a:endParaRPr lang="en-US" sz="1400" dirty="0"/>
           </a:p>
@@ -11582,7 +11546,7 @@
                 <a:ea typeface="Cambria" pitchFamily="34" charset="-122"/>
                 <a:cs typeface="Cambria" pitchFamily="34" charset="-120"/>
               </a:rPr>
-              <a:t>80 GB</a:t>
+              <a:t>.233</a:t>
             </a:r>
             <a:endParaRPr lang="en-US" sz="3600" dirty="0"/>
           </a:p>
@@ -11618,7 +11582,7 @@
                   <a:schemeClr val="tx1"/>
                 </a:solidFill>
               </a:rPr>
-              <a:t>SSD (imágenes ~6 GB + capturas)</a:t>
+              <a:t>IVR+VMS: FreeSWITCH, UEs de prueba, UI (4 vCPU · 8 GB)</a:t>
             </a:r>
             <a:endParaRPr lang="en-US" sz="1400" dirty="0"/>
           </a:p>
@@ -11684,7 +11648,7 @@
                 <a:ea typeface="Cambria" pitchFamily="34" charset="-122"/>
                 <a:cs typeface="Cambria" pitchFamily="34" charset="-120"/>
               </a:rPr>
-              <a:t>Linux</a:t>
+              <a:t>8090</a:t>
             </a:r>
             <a:endParaRPr lang="en-US" sz="3600" dirty="0"/>
           </a:p>
@@ -11720,7 +11684,7 @@
                   <a:schemeClr val="tx1"/>
                 </a:solidFill>
               </a:rPr>
-              <a:t>kernel con xfrm/esp4 y nftables</a:t>
+              <a:t>UI web en los tres nodos (malla de ingreso de Swarm)</a:t>
             </a:r>
             <a:endParaRPr lang="en-US" sz="1400" dirty="0"/>
           </a:p>
@@ -11760,7 +11724,7 @@
                   <a:schemeClr val="tx1"/>
                 </a:solidFill>
               </a:rPr>
-              <a:t>Docker Engine + Compose v2; acceso SSH al repositorio hacom-ivr.</a:t>
+              <a:t>Redes overlay: mims3_network (IMS, 172.32.0.0/24), mims3_isc (ISC, 172.33.0.0/24) y mims3_management (proxies Docker de la UI).</a:t>
             </a:r>
             <a:endParaRPr lang="en-US" sz="1500" dirty="0"/>
           </a:p>
@@ -11778,7 +11742,7 @@
                   <a:schemeClr val="tx1"/>
                 </a:solidFill>
               </a:rPr>
-              <a:t>Red: ruta de la LAN/VPN de desarrollo hacia 172.32.0.0/24 (sin NAT: IPsec ESP no atraviesa NAT sin UDP-encap).</a:t>
+              <a:t>Ajustes de Swarm: SA IPsec sobre la IP de la tarea del P-CSCF (ESP no pasa por la VIP), Kamailio en todas sus redes (mhomed) y FreeSWITCH en la IP overlay.</a:t>
             </a:r>
             <a:endParaRPr lang="en-US" sz="1500" dirty="0"/>
           </a:p>
@@ -11796,7 +11760,7 @@
                   <a:schemeClr val="tx1"/>
                 </a:solidFill>
               </a:rPr>
-              <a:t>Puerto 8090/TCP para la UI de operación; UDP 5060 y 6100-6109/5100-5109 del P-CSCF.</a:t>
+              <a:t>Límite de infraestructura: el underlay de 1500 B deja la overlay en 1450 B; con jumbo frames (MTU ≥ 2200) se cumpliría la regla G3.</a:t>
             </a:r>
             <a:endParaRPr lang="en-US" sz="1500" dirty="0"/>
           </a:p>

</xml_diff>